<commit_message>
Renomeia frequencia para regencia e atualiza nome da instituicao para Complexo Paulo Vargas
</commit_message>
<xml_diff>
--- a/apresentacao/BI_Regencia_Apresentacao.pptx
+++ b/apresentacao/BI_Regencia_Apresentacao.pptx
@@ -3231,7 +3231,7 @@
                 </a:solidFill>
                 <a:latin typeface="Inter"/>
               </a:rPr>
-              <a:t>SENAI · SERVIÇO NACIONAL DE APRENDIZAGEM INDUSTRIAL</a:t>
+              <a:t>Complexo de Educação, Tecnologia, Inovação e Saúde Paulo Vargas</a:t>
             </a:r>
           </a:p>
         </p:txBody>
@@ -3309,7 +3309,7 @@
                 </a:solidFill>
                 <a:latin typeface="Inter"/>
               </a:rPr>
-              <a:t>Frequência dos instrutores em sala de aula — quadro 2026</a:t>
+              <a:t>Regência dos instrutores em sala de aula — quadro 2026</a:t>
             </a:r>
           </a:p>
         </p:txBody>
@@ -3392,7 +3392,7 @@
                 </a:solidFill>
                 <a:latin typeface="Inter"/>
               </a:rPr>
-              <a:t>Escola SENAI Vila Canaã · Departamento Regional de Goiás</a:t>
+              <a:t>Departamento Regional de Goiás</a:t>
             </a:r>
           </a:p>
         </p:txBody>
@@ -3803,7 +3803,7 @@
                 </a:solidFill>
                 <a:latin typeface="Inter"/>
               </a:rPr>
-              <a:t>(JD) = rótulo interno do polo da escola parceira (Col. Est. Jardim Vila Boa / SEDUC) — confirmar com a coordenação.</a:t>
+              <a:t>(JD) = polo do treinamento John Deere (mesma área, em outro local).</a:t>
             </a:r>
           </a:p>
           <a:p>
@@ -3828,7 +3828,7 @@
                 </a:solidFill>
                 <a:latin typeface="Inter"/>
               </a:rPr>
-              <a:t>Frequência média da área: ~46% — 7 de 13 abaixo de 50%.</a:t>
+              <a:t>Regência média da área: ~46% — 7 de 13 abaixo de 50%.</a:t>
             </a:r>
           </a:p>
           <a:p>
@@ -3853,7 +3853,7 @@
                 </a:solidFill>
                 <a:latin typeface="Inter"/>
               </a:rPr>
-              <a:t>Novo filtro POLO/LOCAL: separa Vila Canaã × Jardim Vila Boa (SEDUC) sem fragmentar a área.</a:t>
+              <a:t>Novo filtro POLO/LOCAL: separa Complexo de Educação, Tecnologia, Inovação e Saúde Paulo Vargas × John Deere sem fragmentar a área.</a:t>
             </a:r>
           </a:p>
           <a:p>
@@ -4095,7 +4095,7 @@
                 </a:solidFill>
                 <a:latin typeface="Inter"/>
               </a:rPr>
-              <a:t>Referências internas de alta frequência</a:t>
+              <a:t>Referências internas de alta regência</a:t>
             </a:r>
           </a:p>
         </p:txBody>
@@ -4250,7 +4250,7 @@
                 </a:solidFill>
                 <a:latin typeface="Inter"/>
               </a:rPr>
-              <a:t>ROMULO FLORIANO LIMEIRA: 109,5% — maior frequência (1.314 h).</a:t>
+              <a:t>ROMULO FLORIANO LIMEIRA: 109,5% — maior regência (1.314 h).</a:t>
             </a:r>
           </a:p>
           <a:p>
@@ -4517,7 +4517,7 @@
                 </a:solidFill>
                 <a:latin typeface="Inter"/>
               </a:rPr>
-              <a:t>Frequência célula a célula</a:t>
+              <a:t>Regência célula a célula</a:t>
             </a:r>
           </a:p>
         </p:txBody>
@@ -4672,7 +4672,7 @@
                 </a:solidFill>
                 <a:latin typeface="Inter"/>
               </a:rPr>
-              <a:t>Cada célula = frequência de um instrutor em um mês.</a:t>
+              <a:t>Cada célula = regência de um instrutor em um mês.</a:t>
             </a:r>
           </a:p>
           <a:p>
@@ -5488,7 +5488,7 @@
                 </a:solidFill>
                 <a:latin typeface="Inter"/>
               </a:rPr>
-              <a:t>1. Validar com a coordenação os casos de baixa frequência (quem, por quê, o que fazer).</a:t>
+              <a:t>1. Validar com a coordenação os casos de baixa regência (quem, por quê, o que fazer).</a:t>
             </a:r>
           </a:p>
           <a:p>
@@ -5563,7 +5563,7 @@
                 </a:solidFill>
                 <a:latin typeface="Inter"/>
               </a:rPr>
-              <a:t>    · Definir hoje o que significa "(JD)" e criar campo POLO/LOCAL.</a:t>
+              <a:t>    · Registrar POLO/LOCAL na planilha-fonte (ex.: polo "John Deere").</a:t>
             </a:r>
           </a:p>
           <a:p>
@@ -5588,7 +5588,7 @@
                 </a:solidFill>
                 <a:latin typeface="Inter"/>
               </a:rPr>
-              <a:t>3. Definir metas de frequência por período (respeitando férias e sazonalidade).</a:t>
+              <a:t>3. Definir metas de regência por período (respeitando férias e sazonalidade).</a:t>
             </a:r>
           </a:p>
           <a:p>
@@ -6089,7 +6089,7 @@
                 </a:solidFill>
                 <a:latin typeface="Inter"/>
               </a:rPr>
-              <a:t>Conceito-chave — Frequência:</a:t>
+              <a:t>Conceito-chave — Regência:</a:t>
             </a:r>
           </a:p>
         </p:txBody>
@@ -6137,7 +6137,7 @@
                 </a:solidFill>
                 <a:latin typeface="Inter"/>
               </a:rPr>
-              <a:t>Frequência (%) = horas-aula realizadas ÷ carga de regência esperada no mês.</a:t>
+              <a:t>Regência (%) = horas-aula realizadas ÷ carga de regência esperada no mês.</a:t>
             </a:r>
           </a:p>
           <a:p>
@@ -7322,7 +7322,7 @@
                 </a:solidFill>
                 <a:latin typeface="Inter"/>
               </a:rPr>
-              <a:t>FREQUÊNCIA MÉDIA</a:t>
+              <a:t>REGÊNCIA MÉDIA</a:t>
             </a:r>
           </a:p>
         </p:txBody>
@@ -7361,7 +7361,7 @@
                 </a:solidFill>
                 <a:latin typeface="Inter"/>
               </a:rPr>
-              <a:t>média das frequências mensais</a:t>
+              <a:t>média das regências mensais</a:t>
             </a:r>
           </a:p>
         </p:txBody>
@@ -7906,7 +7906,7 @@
                 </a:solidFill>
                 <a:latin typeface="Inter"/>
               </a:rPr>
-              <a:t>16 instrutores entre 70% e 100% de frequência.</a:t>
+              <a:t>16 instrutores entre 70% e 100% de regência.</a:t>
             </a:r>
           </a:p>
           <a:p>
@@ -8109,7 +8109,7 @@
                 </a:solidFill>
                 <a:latin typeface="Inter"/>
               </a:rPr>
-              <a:t>Sazonalidade — frequência por mês</a:t>
+              <a:t>Sazonalidade — regência por mês</a:t>
             </a:r>
           </a:p>
         </p:txBody>
@@ -8978,7 +8978,7 @@
                 </a:solidFill>
                 <a:latin typeface="Inter"/>
               </a:rPr>
-              <a:t>Distribuição da frequência média</a:t>
+              <a:t>Distribuição da regência média</a:t>
             </a:r>
           </a:p>
         </p:txBody>
@@ -9425,7 +9425,7 @@
                 </a:solidFill>
                 <a:latin typeface="Inter"/>
               </a:rPr>
-              <a:t>Frequência média por área</a:t>
+              <a:t>Regência média por área</a:t>
             </a:r>
           </a:p>
         </p:txBody>
@@ -9897,7 +9897,7 @@
                 </a:solidFill>
                 <a:latin typeface="Inter"/>
               </a:rPr>
-              <a:t>Pontos de atenção — menores frequências</a:t>
+              <a:t>Pontos de atenção — menores regências</a:t>
             </a:r>
           </a:p>
         </p:txBody>

</xml_diff>